<commit_message>
Use latest deck; add browser-viewable slides PDF
- Replace the deck with the user's latest PPTX (validated: opens cleanly,
  no Content_Types defects, 14 slides).
- Add a PDF rendition of the deck so it can be viewed in-browser on GitHub
  (GitHub cannot preview .pptx inline).
- README: offer "View slides (PDF)" alongside the editable PPTX download;
  note the speaker script lives in the deck's notes pane.

Co-Authored-By: Claude Opus 4.8 <noreply@anthropic.com>
Claude-Session: https://claude.ai/code/session_01K8FZSdwKY5W6pJMXYfyn19
</commit_message>
<xml_diff>
--- a/docs/EMBLEMNLP_Tokenomics_Presentation_Slides_and_Script.pptx
+++ b/docs/EMBLEMNLP_Tokenomics_Presentation_Slides_and_Script.pptx
@@ -5,7 +5,7 @@
     <p:sldMasterId id="2147483648" r:id="rId1"/>
   </p:sldMasterIdLst>
   <p:sldIdLst>
-    <p:sldId id="256" r:id="rId2"/>
+    <p:sldId id="270" r:id="rId21"/>
     <p:sldId id="257" r:id="rId3"/>
     <p:sldId id="258" r:id="rId4"/>
     <p:sldId id="259" r:id="rId5"/>
@@ -467,94 +467,6 @@
     </a:lvl9pPr>
   </p:notesStyle>
 </p:notesMaster>
-</file>
-
-<file path=ppt/notesSlides/notesSlide1.xml><?xml version="1.0" encoding="utf-8"?>
-<p:notes xmlns:a="http://schemas.openxmlformats.org/drawingml/2006/main" xmlns:r="http://schemas.openxmlformats.org/officeDocument/2006/relationships" xmlns:p="http://schemas.openxmlformats.org/presentationml/2006/main">
-  <p:cSld>
-    <p:spTree>
-      <p:nvGrpSpPr>
-        <p:cNvPr id="1" name=""/>
-        <p:cNvGrpSpPr/>
-        <p:nvPr/>
-      </p:nvGrpSpPr>
-      <p:grpSpPr>
-        <a:xfrm>
-          <a:off x="0" y="0"/>
-          <a:ext cx="0" cy="0"/>
-          <a:chOff x="0" y="0"/>
-          <a:chExt cx="0" cy="0"/>
-        </a:xfrm>
-      </p:grpSpPr>
-      <p:sp>
-        <p:nvSpPr>
-          <p:cNvPr id="2" name="Slide Image Placeholder 1"/>
-          <p:cNvSpPr>
-            <a:spLocks noGrp="1" noRot="1" noChangeAspect="1"/>
-          </p:cNvSpPr>
-          <p:nvPr>
-            <p:ph type="sldImg"/>
-          </p:nvPr>
-        </p:nvSpPr>
-        <p:spPr/>
-      </p:sp>
-      <p:sp>
-        <p:nvSpPr>
-          <p:cNvPr id="3" name="Notes Placeholder 2"/>
-          <p:cNvSpPr>
-            <a:spLocks noGrp="1"/>
-          </p:cNvSpPr>
-          <p:nvPr>
-            <p:ph type="body" idx="1"/>
-          </p:nvPr>
-        </p:nvSpPr>
-        <p:spPr/>
-        <p:txBody>
-          <a:bodyPr/>
-          <a:lstStyle/>
-          <a:p>
-            <a:r>
-              <a:rPr lang="en-US" dirty="0"/>
-              <a:t>Open by framing this as an engineering decision, not a notation preference. The question is simple: when we send large structured data to models, how much do we pay in tokens, what accuracy do we lose or gain, and what reliability risk do we create downstream? This deck turns the corrected 17-page EMBLEM-NLP research note into a decision path for production prompt and API design.</a:t>
-            </a:r>
-            <a:endParaRPr lang="en-US" dirty="0"/>
-          </a:p>
-        </p:txBody>
-      </p:sp>
-      <p:sp>
-        <p:nvSpPr>
-          <p:cNvPr id="4" name="Slide Number Placeholder 3"/>
-          <p:cNvSpPr>
-            <a:spLocks noGrp="1"/>
-          </p:cNvSpPr>
-          <p:nvPr>
-            <p:ph type="sldNum" sz="quarter" idx="10"/>
-          </p:nvPr>
-        </p:nvSpPr>
-        <p:spPr/>
-        <p:txBody>
-          <a:bodyPr/>
-          <a:lstStyle/>
-          <a:p>
-            <a:fld id="{F7021451-1387-4CA6-816F-3879F97B5CBC}" type="slidenum">
-              <a:rPr lang="en-US"/>
-              <a:t>1</a:t>
-            </a:fld>
-            <a:endParaRPr lang="en-US"/>
-          </a:p>
-        </p:txBody>
-      </p:sp>
-    </p:spTree>
-    <p:extLst>
-      <p:ext uri="{BB962C8B-B14F-4D97-AF65-F5344CB8AC3E}">
-        <p14:creationId xmlns:p14="http://schemas.microsoft.com/office/powerpoint/2010/main" val="1024086991"/>
-      </p:ext>
-    </p:extLst>
-  </p:cSld>
-  <p:clrMapOvr>
-    <a:masterClrMapping/>
-  </p:clrMapOvr>
-</p:notes>
 </file>
 
 <file path=ppt/notesSlides/notesSlide10.xml><?xml version="1.0" encoding="utf-8"?>
@@ -2009,439 +1921,39 @@
 </file>
 
 <file path=ppt/slides/slide1.xml><?xml version="1.0" encoding="utf-8"?>
-<p:sld xmlns:a="http://schemas.openxmlformats.org/drawingml/2006/main" xmlns:r="http://schemas.openxmlformats.org/officeDocument/2006/relationships" xmlns:p="http://schemas.openxmlformats.org/presentationml/2006/main">
-  <p:cSld name="Slide 1">
-    <p:bg>
-      <p:bgPr>
-        <a:solidFill>
-          <a:srgbClr val="F4F6FA"/>
-        </a:solidFill>
-      </p:bgPr>
-    </p:bg>
+<p:sld xmlns:a="http://schemas.openxmlformats.org/drawingml/2006/main" xmlns:p="http://schemas.openxmlformats.org/presentationml/2006/main" xmlns:r="http://schemas.openxmlformats.org/officeDocument/2006/relationships">
+  <p:cSld>
     <p:spTree>
       <p:nvGrpSpPr>
         <p:cNvPr id="1" name=""/>
         <p:cNvGrpSpPr/>
         <p:nvPr/>
       </p:nvGrpSpPr>
-      <p:grpSpPr>
-        <a:xfrm>
-          <a:off x="0" y="0"/>
-          <a:ext cx="0" cy="0"/>
-          <a:chOff x="0" y="0"/>
-          <a:chExt cx="0" cy="0"/>
-        </a:xfrm>
-      </p:grpSpPr>
-      <p:sp>
-        <p:nvSpPr>
-          <p:cNvPr id="2" name="Shape 0"/>
-          <p:cNvSpPr/>
-          <p:nvPr/>
-        </p:nvSpPr>
-        <p:spPr>
-          <a:xfrm>
-            <a:off x="10652760" y="301752"/>
-            <a:ext cx="960120" cy="960120"/>
-          </a:xfrm>
-          <a:prstGeom prst="rect">
-            <a:avLst/>
-          </a:prstGeom>
-          <a:solidFill>
-            <a:srgbClr val="1957D2"/>
-          </a:solidFill>
-          <a:ln w="12700">
-            <a:solidFill>
-              <a:srgbClr val="1957D2"/>
-            </a:solidFill>
-            <a:prstDash val="solid"/>
-          </a:ln>
-        </p:spPr>
-      </p:sp>
+      <p:grpSpPr/>
       <p:pic>
         <p:nvPicPr>
-          <p:cNvPr id="3" name="Image 0" descr="/mnt/data/tokenomics_assets/cover_right.png">    </p:cNvPr>
+          <p:cNvPr id="2" name="Picture 1" descr="70d73eaa-097b-5b96-ab36-e3607445c3a2.png"/>
           <p:cNvPicPr>
             <a:picLocks noChangeAspect="1"/>
           </p:cNvPicPr>
           <p:nvPr/>
         </p:nvPicPr>
         <p:blipFill>
-          <a:blip r:embed="rId1"/>
+          <a:blip r:embed="rId4"/>
           <a:stretch>
             <a:fillRect/>
           </a:stretch>
         </p:blipFill>
         <p:spPr>
           <a:xfrm>
-            <a:off x="6446520" y="0"/>
-            <a:ext cx="5742432" cy="6858000"/>
+            <a:off x="0" y="0"/>
+            <a:ext cx="12192000" cy="6858000"/>
           </a:xfrm>
           <a:prstGeom prst="rect">
             <a:avLst/>
           </a:prstGeom>
         </p:spPr>
       </p:pic>
-      <p:sp>
-        <p:nvSpPr>
-          <p:cNvPr id="4" name="Text 1"/>
-          <p:cNvSpPr/>
-          <p:nvPr/>
-        </p:nvSpPr>
-        <p:spPr>
-          <a:xfrm>
-            <a:off x="621792" y="548640"/>
-            <a:ext cx="3840480" cy="228600"/>
-          </a:xfrm>
-          <a:prstGeom prst="rect">
-            <a:avLst/>
-          </a:prstGeom>
-          <a:noFill/>
-          <a:ln/>
-        </p:spPr>
-        <p:txBody>
-          <a:bodyPr wrap="square" lIns="0" tIns="0" rIns="0" bIns="0" rtlCol="0" anchor="ctr"/>
-          <a:lstStyle/>
-          <a:p>
-            <a:pPr indent="0" marL="0">
-              <a:buNone/>
-            </a:pPr>
-            <a:r>
-              <a:rPr lang="en-US" sz="950" b="1" dirty="0">
-                <a:solidFill>
-                  <a:srgbClr val="1957D2"/>
-                </a:solidFill>
-                <a:latin typeface="Arial" pitchFamily="34" charset="0"/>
-                <a:ea typeface="Arial" pitchFamily="34" charset="-122"/>
-                <a:cs typeface="Arial" pitchFamily="34" charset="-120"/>
-              </a:rPr>
-              <a:t>EMBLEM-NLP RESEARCH NOTE</a:t>
-            </a:r>
-            <a:endParaRPr lang="en-US" sz="950" dirty="0"/>
-          </a:p>
-        </p:txBody>
-      </p:sp>
-      <p:sp>
-        <p:nvSpPr>
-          <p:cNvPr id="5" name="Shape 2"/>
-          <p:cNvSpPr/>
-          <p:nvPr/>
-        </p:nvSpPr>
-        <p:spPr>
-          <a:xfrm>
-            <a:off x="621792" y="896112"/>
-            <a:ext cx="731520" cy="0"/>
-          </a:xfrm>
-          <a:prstGeom prst="line">
-            <a:avLst/>
-          </a:prstGeom>
-          <a:noFill/>
-          <a:ln w="25400">
-            <a:solidFill>
-              <a:srgbClr val="1957D2"/>
-            </a:solidFill>
-            <a:prstDash val="solid"/>
-          </a:ln>
-        </p:spPr>
-      </p:sp>
-      <p:sp>
-        <p:nvSpPr>
-          <p:cNvPr id="6" name="Text 3"/>
-          <p:cNvSpPr/>
-          <p:nvPr/>
-        </p:nvSpPr>
-        <p:spPr>
-          <a:xfrm>
-            <a:off x="621792" y="1234440"/>
-            <a:ext cx="5394960" cy="2468880"/>
-          </a:xfrm>
-          <a:prstGeom prst="rect">
-            <a:avLst/>
-          </a:prstGeom>
-          <a:noFill/>
-          <a:ln/>
-        </p:spPr>
-        <p:txBody>
-          <a:bodyPr wrap="square" lIns="0" tIns="0" rIns="0" bIns="0" rtlCol="0" anchor="ctr">
-            <a:normAutofit/>
-          </a:bodyPr>
-          <a:lstStyle/>
-          <a:p>
-            <a:pPr indent="0" marL="0">
-              <a:buNone/>
-            </a:pPr>
-            <a:r>
-              <a:rPr lang="en-US" sz="3700" b="1" dirty="0">
-                <a:solidFill>
-                  <a:srgbClr val="111318"/>
-                </a:solidFill>
-                <a:latin typeface="Arial" pitchFamily="34" charset="0"/>
-                <a:ea typeface="Arial" pitchFamily="34" charset="-122"/>
-                <a:cs typeface="Arial" pitchFamily="34" charset="-120"/>
-              </a:rPr>
-              <a:t>The Tokenomics of</a:t>
-            </a:r>
-            <a:endParaRPr lang="en-US" sz="3700" dirty="0"/>
-          </a:p>
-          <a:p>
-            <a:pPr indent="0" marL="0">
-              <a:buNone/>
-            </a:pPr>
-            <a:r>
-              <a:rPr lang="en-US" sz="3700" b="1" dirty="0">
-                <a:solidFill>
-                  <a:srgbClr val="111318"/>
-                </a:solidFill>
-                <a:latin typeface="Arial" pitchFamily="34" charset="0"/>
-                <a:ea typeface="Arial" pitchFamily="34" charset="-122"/>
-                <a:cs typeface="Arial" pitchFamily="34" charset="-120"/>
-              </a:rPr>
-              <a:t>Data-Serialization</a:t>
-            </a:r>
-            <a:endParaRPr lang="en-US" sz="3700" dirty="0"/>
-          </a:p>
-          <a:p>
-            <a:pPr indent="0" marL="0">
-              <a:buNone/>
-            </a:pPr>
-            <a:r>
-              <a:rPr lang="en-US" sz="3700" b="1" dirty="0">
-                <a:solidFill>
-                  <a:srgbClr val="111318"/>
-                </a:solidFill>
-                <a:latin typeface="Arial" pitchFamily="34" charset="0"/>
-                <a:ea typeface="Arial" pitchFamily="34" charset="-122"/>
-                <a:cs typeface="Arial" pitchFamily="34" charset="-120"/>
-              </a:rPr>
-              <a:t>Formats</a:t>
-            </a:r>
-            <a:endParaRPr lang="en-US" sz="3700" dirty="0"/>
-          </a:p>
-        </p:txBody>
-      </p:sp>
-      <p:sp>
-        <p:nvSpPr>
-          <p:cNvPr id="7" name="Text 4"/>
-          <p:cNvSpPr/>
-          <p:nvPr/>
-        </p:nvSpPr>
-        <p:spPr>
-          <a:xfrm>
-            <a:off x="658368" y="4160520"/>
-            <a:ext cx="4114800" cy="640080"/>
-          </a:xfrm>
-          <a:prstGeom prst="rect">
-            <a:avLst/>
-          </a:prstGeom>
-          <a:noFill/>
-          <a:ln/>
-        </p:spPr>
-        <p:txBody>
-          <a:bodyPr wrap="square" lIns="635" tIns="635" rIns="635" bIns="635" rtlCol="0" anchor="t">
-            <a:normAutofit/>
-          </a:bodyPr>
-          <a:lstStyle/>
-          <a:p>
-            <a:pPr indent="0" marL="0">
-              <a:buNone/>
-            </a:pPr>
-            <a:r>
-              <a:rPr lang="en-US" sz="1500" dirty="0">
-                <a:solidFill>
-                  <a:srgbClr val="4E5868"/>
-                </a:solidFill>
-                <a:latin typeface="Arial" pitchFamily="34" charset="0"/>
-                <a:ea typeface="Arial" pitchFamily="34" charset="-122"/>
-                <a:cs typeface="Arial" pitchFamily="34" charset="-120"/>
-              </a:rPr>
-              <a:t>Presentation deck + speaker script</a:t>
-            </a:r>
-            <a:endParaRPr lang="en-US" sz="1500" dirty="0"/>
-          </a:p>
-          <a:p>
-            <a:pPr indent="0" marL="0">
-              <a:buNone/>
-            </a:pPr>
-            <a:r>
-              <a:rPr lang="en-US" sz="1500" dirty="0">
-                <a:solidFill>
-                  <a:srgbClr val="4E5868"/>
-                </a:solidFill>
-                <a:latin typeface="Arial" pitchFamily="34" charset="0"/>
-                <a:ea typeface="Arial" pitchFamily="34" charset="-122"/>
-                <a:cs typeface="Arial" pitchFamily="34" charset="-120"/>
-              </a:rPr>
-              <a:t>June 2026 · Rev 2.1</a:t>
-            </a:r>
-            <a:endParaRPr lang="en-US" sz="1500" dirty="0"/>
-          </a:p>
-        </p:txBody>
-      </p:sp>
-      <p:sp>
-        <p:nvSpPr>
-          <p:cNvPr id="8" name="Text 5"/>
-          <p:cNvSpPr/>
-          <p:nvPr/>
-        </p:nvSpPr>
-        <p:spPr>
-          <a:xfrm>
-            <a:off x="658368" y="5074920"/>
-            <a:ext cx="4754880" cy="566928"/>
-          </a:xfrm>
-          <a:prstGeom prst="rect">
-            <a:avLst/>
-          </a:prstGeom>
-          <a:noFill/>
-          <a:ln/>
-        </p:spPr>
-        <p:txBody>
-          <a:bodyPr wrap="square" lIns="0" tIns="0" rIns="0" bIns="0" rtlCol="0" anchor="ctr">
-            <a:normAutofit/>
-          </a:bodyPr>
-          <a:lstStyle/>
-          <a:p>
-            <a:pPr indent="0" marL="0">
-              <a:buNone/>
-            </a:pPr>
-            <a:r>
-              <a:rPr lang="en-US" sz="1350" dirty="0">
-                <a:solidFill>
-                  <a:srgbClr val="4E5868"/>
-                </a:solidFill>
-                <a:latin typeface="Arial" pitchFamily="34" charset="0"/>
-                <a:ea typeface="Arial" pitchFamily="34" charset="-122"/>
-                <a:cs typeface="Arial" pitchFamily="34" charset="-120"/>
-              </a:rPr>
-              <a:t>Cross-provider engineering reference to serialization-format efficiency, tokenizer behavior, pricing, and reliability.</a:t>
-            </a:r>
-            <a:endParaRPr lang="en-US" sz="1350" dirty="0"/>
-          </a:p>
-        </p:txBody>
-      </p:sp>
-      <p:sp>
-        <p:nvSpPr>
-          <p:cNvPr id="9" name="Shape 6"/>
-          <p:cNvSpPr/>
-          <p:nvPr/>
-        </p:nvSpPr>
-        <p:spPr>
-          <a:xfrm>
-            <a:off x="594360" y="6428232"/>
-            <a:ext cx="10835640" cy="0"/>
-          </a:xfrm>
-          <a:prstGeom prst="line">
-            <a:avLst/>
-          </a:prstGeom>
-          <a:noFill/>
-          <a:ln w="8890">
-            <a:solidFill>
-              <a:srgbClr val="CBD3DF"/>
-            </a:solidFill>
-            <a:prstDash val="solid"/>
-          </a:ln>
-        </p:spPr>
-      </p:sp>
-      <p:pic>
-        <p:nvPicPr>
-          <p:cNvPr id="10" name="Image 1" descr="/mnt/data/tokenomics_assets/logo_footer.png">    </p:cNvPr>
-          <p:cNvPicPr>
-            <a:picLocks noChangeAspect="1"/>
-          </p:cNvPicPr>
-          <p:nvPr/>
-        </p:nvPicPr>
-        <p:blipFill>
-          <a:blip r:embed="rId2"/>
-          <a:stretch>
-            <a:fillRect/>
-          </a:stretch>
-        </p:blipFill>
-        <p:spPr>
-          <a:xfrm>
-            <a:off x="865280" y="6510528"/>
-            <a:ext cx="820615" cy="228600"/>
-          </a:xfrm>
-          <a:prstGeom prst="rect">
-            <a:avLst/>
-          </a:prstGeom>
-        </p:spPr>
-      </p:pic>
-      <p:sp>
-        <p:nvSpPr>
-          <p:cNvPr id="11" name="Text 7"/>
-          <p:cNvSpPr/>
-          <p:nvPr/>
-        </p:nvSpPr>
-        <p:spPr>
-          <a:xfrm>
-            <a:off x="2057400" y="6510528"/>
-            <a:ext cx="3931920" cy="182880"/>
-          </a:xfrm>
-          <a:prstGeom prst="rect">
-            <a:avLst/>
-          </a:prstGeom>
-          <a:noFill/>
-          <a:ln/>
-        </p:spPr>
-        <p:txBody>
-          <a:bodyPr wrap="square" lIns="0" tIns="0" rIns="0" bIns="0" rtlCol="0" anchor="ctr"/>
-          <a:lstStyle/>
-          <a:p>
-            <a:pPr indent="0" marL="0">
-              <a:buNone/>
-            </a:pPr>
-            <a:r>
-              <a:rPr lang="en-US" sz="750" dirty="0">
-                <a:solidFill>
-                  <a:srgbClr val="6B7280"/>
-                </a:solidFill>
-                <a:latin typeface="Arial" pitchFamily="34" charset="0"/>
-                <a:ea typeface="Arial" pitchFamily="34" charset="-122"/>
-                <a:cs typeface="Arial" pitchFamily="34" charset="-120"/>
-              </a:rPr>
-              <a:t>Prompt Ecology, Reverse Engineering —Embodied Agencies</a:t>
-            </a:r>
-            <a:endParaRPr lang="en-US" sz="750" dirty="0"/>
-          </a:p>
-        </p:txBody>
-      </p:sp>
-      <p:sp>
-        <p:nvSpPr>
-          <p:cNvPr id="12" name="Text 8"/>
-          <p:cNvSpPr/>
-          <p:nvPr/>
-        </p:nvSpPr>
-        <p:spPr>
-          <a:xfrm>
-            <a:off x="11064240" y="6473952"/>
-            <a:ext cx="548640" cy="228600"/>
-          </a:xfrm>
-          <a:prstGeom prst="rect">
-            <a:avLst/>
-          </a:prstGeom>
-          <a:noFill/>
-          <a:ln/>
-        </p:spPr>
-        <p:txBody>
-          <a:bodyPr wrap="square" lIns="0" tIns="0" rIns="0" bIns="0" rtlCol="0" anchor="ctr"/>
-          <a:lstStyle/>
-          <a:p>
-            <a:pPr algn="r" indent="0" marL="0">
-              <a:buNone/>
-            </a:pPr>
-            <a:r>
-              <a:rPr lang="en-US" sz="850" b="1" dirty="0">
-                <a:solidFill>
-                  <a:srgbClr val="1957D2"/>
-                </a:solidFill>
-                <a:latin typeface="Arial" pitchFamily="34" charset="0"/>
-                <a:ea typeface="Arial" pitchFamily="34" charset="-122"/>
-                <a:cs typeface="Arial" pitchFamily="34" charset="-120"/>
-              </a:rPr>
-              <a:t>01</a:t>
-            </a:r>
-            <a:endParaRPr lang="en-US" sz="850" dirty="0"/>
-          </a:p>
-        </p:txBody>
-      </p:sp>
     </p:spTree>
   </p:cSld>
   <p:clrMapOvr>
@@ -2829,24 +2341,26 @@
         </p:nvSpPr>
         <p:spPr>
           <a:xfrm>
-            <a:off x="2057400" y="6510528"/>
-            <a:ext cx="3931920" cy="182880"/>
-          </a:xfrm>
-          <a:prstGeom prst="rect">
-            <a:avLst/>
-          </a:prstGeom>
-          <a:noFill/>
-          <a:ln/>
-        </p:spPr>
-        <p:txBody>
-          <a:bodyPr wrap="square" lIns="0" tIns="0" rIns="0" bIns="0" rtlCol="0" anchor="ctr"/>
+            <a:off x="1874520" y="6510528"/>
+            <a:ext cx="4389120" cy="182880"/>
+          </a:xfrm>
+          <a:prstGeom prst="rect">
+            <a:avLst/>
+          </a:prstGeom>
+          <a:noFill/>
+          <a:ln/>
+        </p:spPr>
+        <p:txBody>
+          <a:bodyPr wrap="square" lIns="0" tIns="0" rIns="0" bIns="0" rtlCol="0" anchor="ctr">
+            <a:normAutofit/>
+          </a:bodyPr>
           <a:lstStyle/>
           <a:p>
             <a:pPr indent="0" marL="0">
               <a:buNone/>
             </a:pPr>
             <a:r>
-              <a:rPr lang="en-US" sz="750" dirty="0">
+              <a:rPr lang="en-US" sz="660" dirty="0">
                 <a:solidFill>
                   <a:srgbClr val="6B7280"/>
                 </a:solidFill>
@@ -2854,9 +2368,9 @@
                 <a:ea typeface="Arial" pitchFamily="34" charset="-122"/>
                 <a:cs typeface="Arial" pitchFamily="34" charset="-120"/>
               </a:rPr>
-              <a:t>Prompt Ecology, Reverse Engineering —Embodied Agencies</a:t>
-            </a:r>
-            <a:endParaRPr lang="en-US" sz="750" dirty="0"/>
+              <a:t>EMBLEM-NLP | Prompt Ecology, Reverse Engineering —Embodied Agencies.</a:t>
+            </a:r>
+            <a:endParaRPr lang="en-US" sz="660" dirty="0"/>
           </a:p>
         </p:txBody>
       </p:sp>
@@ -3099,8 +2613,8 @@
         </p:blipFill>
         <p:spPr>
           <a:xfrm>
-            <a:off x="6263640" y="1864995"/>
-            <a:ext cx="4983480" cy="2076450"/>
+            <a:off x="6263640" y="1820422"/>
+            <a:ext cx="4983480" cy="2165596"/>
           </a:xfrm>
           <a:prstGeom prst="rect">
             <a:avLst/>
@@ -3203,24 +2717,26 @@
         </p:nvSpPr>
         <p:spPr>
           <a:xfrm>
-            <a:off x="2057400" y="6510528"/>
-            <a:ext cx="3931920" cy="182880"/>
-          </a:xfrm>
-          <a:prstGeom prst="rect">
-            <a:avLst/>
-          </a:prstGeom>
-          <a:noFill/>
-          <a:ln/>
-        </p:spPr>
-        <p:txBody>
-          <a:bodyPr wrap="square" lIns="0" tIns="0" rIns="0" bIns="0" rtlCol="0" anchor="ctr"/>
+            <a:off x="1874520" y="6510528"/>
+            <a:ext cx="4389120" cy="182880"/>
+          </a:xfrm>
+          <a:prstGeom prst="rect">
+            <a:avLst/>
+          </a:prstGeom>
+          <a:noFill/>
+          <a:ln/>
+        </p:spPr>
+        <p:txBody>
+          <a:bodyPr wrap="square" lIns="0" tIns="0" rIns="0" bIns="0" rtlCol="0" anchor="ctr">
+            <a:normAutofit/>
+          </a:bodyPr>
           <a:lstStyle/>
           <a:p>
             <a:pPr indent="0" marL="0">
               <a:buNone/>
             </a:pPr>
             <a:r>
-              <a:rPr lang="en-US" sz="750" dirty="0">
+              <a:rPr lang="en-US" sz="660" dirty="0">
                 <a:solidFill>
                   <a:srgbClr val="6B7280"/>
                 </a:solidFill>
@@ -3228,9 +2744,9 @@
                 <a:ea typeface="Arial" pitchFamily="34" charset="-122"/>
                 <a:cs typeface="Arial" pitchFamily="34" charset="-120"/>
               </a:rPr>
-              <a:t>Prompt Ecology, Reverse Engineering —Embodied Agencies</a:t>
-            </a:r>
-            <a:endParaRPr lang="en-US" sz="750" dirty="0"/>
+              <a:t>EMBLEM-NLP | Prompt Ecology, Reverse Engineering —Embodied Agencies.</a:t>
+            </a:r>
+            <a:endParaRPr lang="en-US" sz="660" dirty="0"/>
           </a:p>
         </p:txBody>
       </p:sp>
@@ -3660,24 +3176,26 @@
         </p:nvSpPr>
         <p:spPr>
           <a:xfrm>
-            <a:off x="2057400" y="6510528"/>
-            <a:ext cx="3931920" cy="182880"/>
-          </a:xfrm>
-          <a:prstGeom prst="rect">
-            <a:avLst/>
-          </a:prstGeom>
-          <a:noFill/>
-          <a:ln/>
-        </p:spPr>
-        <p:txBody>
-          <a:bodyPr wrap="square" lIns="0" tIns="0" rIns="0" bIns="0" rtlCol="0" anchor="ctr"/>
+            <a:off x="1874520" y="6510528"/>
+            <a:ext cx="4389120" cy="182880"/>
+          </a:xfrm>
+          <a:prstGeom prst="rect">
+            <a:avLst/>
+          </a:prstGeom>
+          <a:noFill/>
+          <a:ln/>
+        </p:spPr>
+        <p:txBody>
+          <a:bodyPr wrap="square" lIns="0" tIns="0" rIns="0" bIns="0" rtlCol="0" anchor="ctr">
+            <a:normAutofit/>
+          </a:bodyPr>
           <a:lstStyle/>
           <a:p>
             <a:pPr indent="0" marL="0">
               <a:buNone/>
             </a:pPr>
             <a:r>
-              <a:rPr lang="en-US" sz="750" dirty="0">
+              <a:rPr lang="en-US" sz="660" dirty="0">
                 <a:solidFill>
                   <a:srgbClr val="6B7280"/>
                 </a:solidFill>
@@ -3685,9 +3203,9 @@
                 <a:ea typeface="Arial" pitchFamily="34" charset="-122"/>
                 <a:cs typeface="Arial" pitchFamily="34" charset="-120"/>
               </a:rPr>
-              <a:t>Prompt Ecology, Reverse Engineering —Embodied Agencies</a:t>
-            </a:r>
-            <a:endParaRPr lang="en-US" sz="750" dirty="0"/>
+              <a:t>EMBLEM-NLP | Prompt Ecology, Reverse Engineering —Embodied Agencies.</a:t>
+            </a:r>
+            <a:endParaRPr lang="en-US" sz="660" dirty="0"/>
           </a:p>
         </p:txBody>
       </p:sp>
@@ -3906,8 +3424,8 @@
         </p:blipFill>
         <p:spPr>
           <a:xfrm>
-            <a:off x="832770" y="1417320"/>
-            <a:ext cx="6234876" cy="4526280"/>
+            <a:off x="658368" y="1694906"/>
+            <a:ext cx="6583680" cy="3971109"/>
           </a:xfrm>
           <a:prstGeom prst="rect">
             <a:avLst/>
@@ -4106,24 +3624,26 @@
         </p:nvSpPr>
         <p:spPr>
           <a:xfrm>
-            <a:off x="2057400" y="6510528"/>
-            <a:ext cx="3931920" cy="182880"/>
-          </a:xfrm>
-          <a:prstGeom prst="rect">
-            <a:avLst/>
-          </a:prstGeom>
-          <a:noFill/>
-          <a:ln/>
-        </p:spPr>
-        <p:txBody>
-          <a:bodyPr wrap="square" lIns="0" tIns="0" rIns="0" bIns="0" rtlCol="0" anchor="ctr"/>
+            <a:off x="1874520" y="6510528"/>
+            <a:ext cx="4389120" cy="182880"/>
+          </a:xfrm>
+          <a:prstGeom prst="rect">
+            <a:avLst/>
+          </a:prstGeom>
+          <a:noFill/>
+          <a:ln/>
+        </p:spPr>
+        <p:txBody>
+          <a:bodyPr wrap="square" lIns="0" tIns="0" rIns="0" bIns="0" rtlCol="0" anchor="ctr">
+            <a:normAutofit/>
+          </a:bodyPr>
           <a:lstStyle/>
           <a:p>
             <a:pPr indent="0" marL="0">
               <a:buNone/>
             </a:pPr>
             <a:r>
-              <a:rPr lang="en-US" sz="750" dirty="0">
+              <a:rPr lang="en-US" sz="660" dirty="0">
                 <a:solidFill>
                   <a:srgbClr val="6B7280"/>
                 </a:solidFill>
@@ -4131,9 +3651,9 @@
                 <a:ea typeface="Arial" pitchFamily="34" charset="-122"/>
                 <a:cs typeface="Arial" pitchFamily="34" charset="-120"/>
               </a:rPr>
-              <a:t>Prompt Ecology, Reverse Engineering —Embodied Agencies</a:t>
-            </a:r>
-            <a:endParaRPr lang="en-US" sz="750" dirty="0"/>
+              <a:t>EMBLEM-NLP | Prompt Ecology, Reverse Engineering —Embodied Agencies.</a:t>
+            </a:r>
+            <a:endParaRPr lang="en-US" sz="660" dirty="0"/>
           </a:p>
         </p:txBody>
       </p:sp>
@@ -4704,7 +4224,7 @@
         <p:spPr>
           <a:xfrm>
             <a:off x="1280160" y="4507992"/>
-            <a:ext cx="8961120" cy="411480"/>
+            <a:ext cx="8092440" cy="411480"/>
           </a:xfrm>
           <a:prstGeom prst="rect">
             <a:avLst/>
@@ -4745,7 +4265,7 @@
         <p:spPr>
           <a:xfrm>
             <a:off x="777240" y="5532120"/>
-            <a:ext cx="9921240" cy="0"/>
+            <a:ext cx="8823960" cy="0"/>
           </a:xfrm>
           <a:prstGeom prst="line">
             <a:avLst/>
@@ -4768,7 +4288,7 @@
         <p:spPr>
           <a:xfrm>
             <a:off x="777240" y="5687568"/>
-            <a:ext cx="9784080" cy="228600"/>
+            <a:ext cx="8732520" cy="228600"/>
           </a:xfrm>
           <a:prstGeom prst="rect">
             <a:avLst/>
@@ -4808,16 +4328,20 @@
         </p:nvSpPr>
         <p:spPr>
           <a:xfrm>
-            <a:off x="594360" y="6428232"/>
-            <a:ext cx="10835640" cy="0"/>
-          </a:xfrm>
-          <a:prstGeom prst="line">
-            <a:avLst/>
-          </a:prstGeom>
-          <a:noFill/>
+            <a:off x="9921240" y="4590288"/>
+            <a:ext cx="1353312" cy="1170432"/>
+          </a:xfrm>
+          <a:prstGeom prst="roundRect">
+            <a:avLst>
+              <a:gd name="adj" fmla="val 5469"/>
+            </a:avLst>
+          </a:prstGeom>
+          <a:solidFill>
+            <a:srgbClr val="FFFFFF"/>
+          </a:solidFill>
           <a:ln w="8890">
             <a:solidFill>
-              <a:srgbClr val="CBD3DF"/>
+              <a:srgbClr val="D3DAE6"/>
             </a:solidFill>
             <a:prstDash val="solid"/>
           </a:ln>
@@ -4825,7 +4349,7 @@
       </p:sp>
       <p:pic>
         <p:nvPicPr>
-          <p:cNvPr id="19" name="Image 0" descr="/mnt/data/tokenomics_assets/logo_footer.png">    </p:cNvPr>
+          <p:cNvPr id="19" name="Image 0" descr="/mnt/data/tokenomics_assets/qr_github_emblemnlp.png">    </p:cNvPr>
           <p:cNvPicPr>
             <a:picLocks noChangeAspect="1"/>
           </p:cNvPicPr>
@@ -4839,6 +4363,133 @@
         </p:blipFill>
         <p:spPr>
           <a:xfrm>
+            <a:off x="10094976" y="4681728"/>
+            <a:ext cx="658368" cy="658368"/>
+          </a:xfrm>
+          <a:prstGeom prst="rect">
+            <a:avLst/>
+          </a:prstGeom>
+        </p:spPr>
+      </p:pic>
+      <p:sp>
+        <p:nvSpPr>
+          <p:cNvPr id="20" name="Text 17"/>
+          <p:cNvSpPr/>
+          <p:nvPr/>
+        </p:nvSpPr>
+        <p:spPr>
+          <a:xfrm>
+            <a:off x="10040112" y="5376672"/>
+            <a:ext cx="868680" cy="146304"/>
+          </a:xfrm>
+          <a:prstGeom prst="rect">
+            <a:avLst/>
+          </a:prstGeom>
+          <a:noFill/>
+          <a:ln/>
+        </p:spPr>
+        <p:txBody>
+          <a:bodyPr wrap="square" lIns="0" tIns="0" rIns="0" bIns="0" rtlCol="0" anchor="ctr"/>
+          <a:lstStyle/>
+          <a:p>
+            <a:pPr algn="ctr" indent="0" marL="0">
+              <a:buNone/>
+            </a:pPr>
+            <a:r>
+              <a:rPr lang="en-US" sz="760" b="1" dirty="0">
+                <a:solidFill>
+                  <a:srgbClr val="111318"/>
+                </a:solidFill>
+                <a:latin typeface="Arial" pitchFamily="34" charset="0"/>
+                <a:ea typeface="Arial" pitchFamily="34" charset="-122"/>
+                <a:cs typeface="Arial" pitchFamily="34" charset="-120"/>
+              </a:rPr>
+              <a:t>Repository</a:t>
+            </a:r>
+            <a:endParaRPr lang="en-US" sz="760" dirty="0"/>
+          </a:p>
+        </p:txBody>
+      </p:sp>
+      <p:sp>
+        <p:nvSpPr>
+          <p:cNvPr id="21" name="Text 18"/>
+          <p:cNvSpPr/>
+          <p:nvPr/>
+        </p:nvSpPr>
+        <p:spPr>
+          <a:xfrm>
+            <a:off x="9957816" y="5550408"/>
+            <a:ext cx="1261872" cy="146304"/>
+          </a:xfrm>
+          <a:prstGeom prst="rect">
+            <a:avLst/>
+          </a:prstGeom>
+          <a:noFill/>
+          <a:ln/>
+        </p:spPr>
+        <p:txBody>
+          <a:bodyPr wrap="square" lIns="0" tIns="0" rIns="0" bIns="0" rtlCol="0" anchor="ctr">
+            <a:normAutofit/>
+          </a:bodyPr>
+          <a:lstStyle/>
+          <a:p>
+            <a:pPr algn="ctr" indent="0" marL="0">
+              <a:buNone/>
+            </a:pPr>
+            <a:r>
+              <a:rPr lang="en-US" sz="560" dirty="0">
+                <a:solidFill>
+                  <a:srgbClr val="4E5868"/>
+                </a:solidFill>
+                <a:latin typeface="Arial" pitchFamily="34" charset="0"/>
+                <a:ea typeface="Arial" pitchFamily="34" charset="-122"/>
+                <a:cs typeface="Arial" pitchFamily="34" charset="-120"/>
+              </a:rPr>
+              <a:t>github.com/emblem-nlp</a:t>
+            </a:r>
+            <a:endParaRPr lang="en-US" sz="560" dirty="0"/>
+          </a:p>
+        </p:txBody>
+      </p:sp>
+      <p:sp>
+        <p:nvSpPr>
+          <p:cNvPr id="22" name="Shape 19"/>
+          <p:cNvSpPr/>
+          <p:nvPr/>
+        </p:nvSpPr>
+        <p:spPr>
+          <a:xfrm>
+            <a:off x="594360" y="6428232"/>
+            <a:ext cx="10835640" cy="0"/>
+          </a:xfrm>
+          <a:prstGeom prst="line">
+            <a:avLst/>
+          </a:prstGeom>
+          <a:noFill/>
+          <a:ln w="8890">
+            <a:solidFill>
+              <a:srgbClr val="CBD3DF"/>
+            </a:solidFill>
+            <a:prstDash val="solid"/>
+          </a:ln>
+        </p:spPr>
+      </p:sp>
+      <p:pic>
+        <p:nvPicPr>
+          <p:cNvPr id="23" name="Image 1" descr="/mnt/data/tokenomics_assets/logo_footer.png">    </p:cNvPr>
+          <p:cNvPicPr>
+            <a:picLocks noChangeAspect="1"/>
+          </p:cNvPicPr>
+          <p:nvPr/>
+        </p:nvPicPr>
+        <p:blipFill>
+          <a:blip r:embed="rId2"/>
+          <a:stretch>
+            <a:fillRect/>
+          </a:stretch>
+        </p:blipFill>
+        <p:spPr>
+          <a:xfrm>
             <a:off x="865280" y="6510528"/>
             <a:ext cx="820615" cy="228600"/>
           </a:xfrm>
@@ -4849,30 +4500,32 @@
       </p:pic>
       <p:sp>
         <p:nvSpPr>
-          <p:cNvPr id="20" name="Text 17"/>
-          <p:cNvSpPr/>
-          <p:nvPr/>
-        </p:nvSpPr>
-        <p:spPr>
-          <a:xfrm>
-            <a:off x="2057400" y="6510528"/>
-            <a:ext cx="3931920" cy="182880"/>
-          </a:xfrm>
-          <a:prstGeom prst="rect">
-            <a:avLst/>
-          </a:prstGeom>
-          <a:noFill/>
-          <a:ln/>
-        </p:spPr>
-        <p:txBody>
-          <a:bodyPr wrap="square" lIns="0" tIns="0" rIns="0" bIns="0" rtlCol="0" anchor="ctr"/>
+          <p:cNvPr id="24" name="Text 20"/>
+          <p:cNvSpPr/>
+          <p:nvPr/>
+        </p:nvSpPr>
+        <p:spPr>
+          <a:xfrm>
+            <a:off x="1874520" y="6510528"/>
+            <a:ext cx="4389120" cy="182880"/>
+          </a:xfrm>
+          <a:prstGeom prst="rect">
+            <a:avLst/>
+          </a:prstGeom>
+          <a:noFill/>
+          <a:ln/>
+        </p:spPr>
+        <p:txBody>
+          <a:bodyPr wrap="square" lIns="0" tIns="0" rIns="0" bIns="0" rtlCol="0" anchor="ctr">
+            <a:normAutofit/>
+          </a:bodyPr>
           <a:lstStyle/>
           <a:p>
             <a:pPr indent="0" marL="0">
               <a:buNone/>
             </a:pPr>
             <a:r>
-              <a:rPr lang="en-US" sz="750" dirty="0">
+              <a:rPr lang="en-US" sz="660" dirty="0">
                 <a:solidFill>
                   <a:srgbClr val="6B7280"/>
                 </a:solidFill>
@@ -4880,15 +4533,15 @@
                 <a:ea typeface="Arial" pitchFamily="34" charset="-122"/>
                 <a:cs typeface="Arial" pitchFamily="34" charset="-120"/>
               </a:rPr>
-              <a:t>Prompt Ecology, Reverse Engineering —Embodied Agencies</a:t>
-            </a:r>
-            <a:endParaRPr lang="en-US" sz="750" dirty="0"/>
-          </a:p>
-        </p:txBody>
-      </p:sp>
-      <p:sp>
-        <p:nvSpPr>
-          <p:cNvPr id="21" name="Text 18"/>
+              <a:t>EMBLEM-NLP | Prompt Ecology, Reverse Engineering —Embodied Agencies.</a:t>
+            </a:r>
+            <a:endParaRPr lang="en-US" sz="660" dirty="0"/>
+          </a:p>
+        </p:txBody>
+      </p:sp>
+      <p:sp>
+        <p:nvSpPr>
+          <p:cNvPr id="25" name="Text 21"/>
           <p:cNvSpPr/>
           <p:nvPr/>
         </p:nvSpPr>
@@ -5798,24 +5451,26 @@
         </p:nvSpPr>
         <p:spPr>
           <a:xfrm>
-            <a:off x="2057400" y="6510528"/>
-            <a:ext cx="3931920" cy="182880"/>
-          </a:xfrm>
-          <a:prstGeom prst="rect">
-            <a:avLst/>
-          </a:prstGeom>
-          <a:noFill/>
-          <a:ln/>
-        </p:spPr>
-        <p:txBody>
-          <a:bodyPr wrap="square" lIns="0" tIns="0" rIns="0" bIns="0" rtlCol="0" anchor="ctr"/>
+            <a:off x="1874520" y="6510528"/>
+            <a:ext cx="4389120" cy="182880"/>
+          </a:xfrm>
+          <a:prstGeom prst="rect">
+            <a:avLst/>
+          </a:prstGeom>
+          <a:noFill/>
+          <a:ln/>
+        </p:spPr>
+        <p:txBody>
+          <a:bodyPr wrap="square" lIns="0" tIns="0" rIns="0" bIns="0" rtlCol="0" anchor="ctr">
+            <a:normAutofit/>
+          </a:bodyPr>
           <a:lstStyle/>
           <a:p>
             <a:pPr indent="0" marL="0">
               <a:buNone/>
             </a:pPr>
             <a:r>
-              <a:rPr lang="en-US" sz="750" dirty="0">
+              <a:rPr lang="en-US" sz="660" dirty="0">
                 <a:solidFill>
                   <a:srgbClr val="6B7280"/>
                 </a:solidFill>
@@ -5823,9 +5478,9 @@
                 <a:ea typeface="Arial" pitchFamily="34" charset="-122"/>
                 <a:cs typeface="Arial" pitchFamily="34" charset="-120"/>
               </a:rPr>
-              <a:t>Prompt Ecology, Reverse Engineering —Embodied Agencies</a:t>
-            </a:r>
-            <a:endParaRPr lang="en-US" sz="750" dirty="0"/>
+              <a:t>EMBLEM-NLP | Prompt Ecology, Reverse Engineering —Embodied Agencies.</a:t>
+            </a:r>
+            <a:endParaRPr lang="en-US" sz="660" dirty="0"/>
           </a:p>
         </p:txBody>
       </p:sp>
@@ -6620,24 +6275,26 @@
         </p:nvSpPr>
         <p:spPr>
           <a:xfrm>
-            <a:off x="2057400" y="6510528"/>
-            <a:ext cx="3931920" cy="182880"/>
-          </a:xfrm>
-          <a:prstGeom prst="rect">
-            <a:avLst/>
-          </a:prstGeom>
-          <a:noFill/>
-          <a:ln/>
-        </p:spPr>
-        <p:txBody>
-          <a:bodyPr wrap="square" lIns="0" tIns="0" rIns="0" bIns="0" rtlCol="0" anchor="ctr"/>
+            <a:off x="1874520" y="6510528"/>
+            <a:ext cx="4389120" cy="182880"/>
+          </a:xfrm>
+          <a:prstGeom prst="rect">
+            <a:avLst/>
+          </a:prstGeom>
+          <a:noFill/>
+          <a:ln/>
+        </p:spPr>
+        <p:txBody>
+          <a:bodyPr wrap="square" lIns="0" tIns="0" rIns="0" bIns="0" rtlCol="0" anchor="ctr">
+            <a:normAutofit/>
+          </a:bodyPr>
           <a:lstStyle/>
           <a:p>
             <a:pPr indent="0" marL="0">
               <a:buNone/>
             </a:pPr>
             <a:r>
-              <a:rPr lang="en-US" sz="750" dirty="0">
+              <a:rPr lang="en-US" sz="660" dirty="0">
                 <a:solidFill>
                   <a:srgbClr val="6B7280"/>
                 </a:solidFill>
@@ -6645,9 +6302,9 @@
                 <a:ea typeface="Arial" pitchFamily="34" charset="-122"/>
                 <a:cs typeface="Arial" pitchFamily="34" charset="-120"/>
               </a:rPr>
-              <a:t>Prompt Ecology, Reverse Engineering —Embodied Agencies</a:t>
-            </a:r>
-            <a:endParaRPr lang="en-US" sz="750" dirty="0"/>
+              <a:t>EMBLEM-NLP | Prompt Ecology, Reverse Engineering —Embodied Agencies.</a:t>
+            </a:r>
+            <a:endParaRPr lang="en-US" sz="660" dirty="0"/>
           </a:p>
         </p:txBody>
       </p:sp>
@@ -7473,24 +7130,26 @@
         </p:nvSpPr>
         <p:spPr>
           <a:xfrm>
-            <a:off x="2057400" y="6510528"/>
-            <a:ext cx="3931920" cy="182880"/>
-          </a:xfrm>
-          <a:prstGeom prst="rect">
-            <a:avLst/>
-          </a:prstGeom>
-          <a:noFill/>
-          <a:ln/>
-        </p:spPr>
-        <p:txBody>
-          <a:bodyPr wrap="square" lIns="0" tIns="0" rIns="0" bIns="0" rtlCol="0" anchor="ctr"/>
+            <a:off x="1874520" y="6510528"/>
+            <a:ext cx="4389120" cy="182880"/>
+          </a:xfrm>
+          <a:prstGeom prst="rect">
+            <a:avLst/>
+          </a:prstGeom>
+          <a:noFill/>
+          <a:ln/>
+        </p:spPr>
+        <p:txBody>
+          <a:bodyPr wrap="square" lIns="0" tIns="0" rIns="0" bIns="0" rtlCol="0" anchor="ctr">
+            <a:normAutofit/>
+          </a:bodyPr>
           <a:lstStyle/>
           <a:p>
             <a:pPr indent="0" marL="0">
               <a:buNone/>
             </a:pPr>
             <a:r>
-              <a:rPr lang="en-US" sz="750" dirty="0">
+              <a:rPr lang="en-US" sz="660" dirty="0">
                 <a:solidFill>
                   <a:srgbClr val="6B7280"/>
                 </a:solidFill>
@@ -7498,9 +7157,9 @@
                 <a:ea typeface="Arial" pitchFamily="34" charset="-122"/>
                 <a:cs typeface="Arial" pitchFamily="34" charset="-120"/>
               </a:rPr>
-              <a:t>Prompt Ecology, Reverse Engineering —Embodied Agencies</a:t>
-            </a:r>
-            <a:endParaRPr lang="en-US" sz="750" dirty="0"/>
+              <a:t>EMBLEM-NLP | Prompt Ecology, Reverse Engineering —Embodied Agencies.</a:t>
+            </a:r>
+            <a:endParaRPr lang="en-US" sz="660" dirty="0"/>
           </a:p>
         </p:txBody>
       </p:sp>
@@ -7930,24 +7589,26 @@
         </p:nvSpPr>
         <p:spPr>
           <a:xfrm>
-            <a:off x="2057400" y="6510528"/>
-            <a:ext cx="3931920" cy="182880"/>
-          </a:xfrm>
-          <a:prstGeom prst="rect">
-            <a:avLst/>
-          </a:prstGeom>
-          <a:noFill/>
-          <a:ln/>
-        </p:spPr>
-        <p:txBody>
-          <a:bodyPr wrap="square" lIns="0" tIns="0" rIns="0" bIns="0" rtlCol="0" anchor="ctr"/>
+            <a:off x="1874520" y="6510528"/>
+            <a:ext cx="4389120" cy="182880"/>
+          </a:xfrm>
+          <a:prstGeom prst="rect">
+            <a:avLst/>
+          </a:prstGeom>
+          <a:noFill/>
+          <a:ln/>
+        </p:spPr>
+        <p:txBody>
+          <a:bodyPr wrap="square" lIns="0" tIns="0" rIns="0" bIns="0" rtlCol="0" anchor="ctr">
+            <a:normAutofit/>
+          </a:bodyPr>
           <a:lstStyle/>
           <a:p>
             <a:pPr indent="0" marL="0">
               <a:buNone/>
             </a:pPr>
             <a:r>
-              <a:rPr lang="en-US" sz="750" dirty="0">
+              <a:rPr lang="en-US" sz="660" dirty="0">
                 <a:solidFill>
                   <a:srgbClr val="6B7280"/>
                 </a:solidFill>
@@ -7955,9 +7616,9 @@
                 <a:ea typeface="Arial" pitchFamily="34" charset="-122"/>
                 <a:cs typeface="Arial" pitchFamily="34" charset="-120"/>
               </a:rPr>
-              <a:t>Prompt Ecology, Reverse Engineering —Embodied Agencies</a:t>
-            </a:r>
-            <a:endParaRPr lang="en-US" sz="750" dirty="0"/>
+              <a:t>EMBLEM-NLP | Prompt Ecology, Reverse Engineering —Embodied Agencies.</a:t>
+            </a:r>
+            <a:endParaRPr lang="en-US" sz="660" dirty="0"/>
           </a:p>
         </p:txBody>
       </p:sp>
@@ -8176,8 +7837,8 @@
         </p:blipFill>
         <p:spPr>
           <a:xfrm>
-            <a:off x="915844" y="1508760"/>
-            <a:ext cx="5474368" cy="4160520"/>
+            <a:off x="1080075" y="1508760"/>
+            <a:ext cx="5145906" cy="4160520"/>
           </a:xfrm>
           <a:prstGeom prst="rect">
             <a:avLst/>
@@ -8607,24 +8268,26 @@
         </p:nvSpPr>
         <p:spPr>
           <a:xfrm>
-            <a:off x="2057400" y="6510528"/>
-            <a:ext cx="3931920" cy="182880"/>
-          </a:xfrm>
-          <a:prstGeom prst="rect">
-            <a:avLst/>
-          </a:prstGeom>
-          <a:noFill/>
-          <a:ln/>
-        </p:spPr>
-        <p:txBody>
-          <a:bodyPr wrap="square" lIns="0" tIns="0" rIns="0" bIns="0" rtlCol="0" anchor="ctr"/>
+            <a:off x="1874520" y="6510528"/>
+            <a:ext cx="4389120" cy="182880"/>
+          </a:xfrm>
+          <a:prstGeom prst="rect">
+            <a:avLst/>
+          </a:prstGeom>
+          <a:noFill/>
+          <a:ln/>
+        </p:spPr>
+        <p:txBody>
+          <a:bodyPr wrap="square" lIns="0" tIns="0" rIns="0" bIns="0" rtlCol="0" anchor="ctr">
+            <a:normAutofit/>
+          </a:bodyPr>
           <a:lstStyle/>
           <a:p>
             <a:pPr indent="0" marL="0">
               <a:buNone/>
             </a:pPr>
             <a:r>
-              <a:rPr lang="en-US" sz="750" dirty="0">
+              <a:rPr lang="en-US" sz="660" dirty="0">
                 <a:solidFill>
                   <a:srgbClr val="6B7280"/>
                 </a:solidFill>
@@ -8632,9 +8295,9 @@
                 <a:ea typeface="Arial" pitchFamily="34" charset="-122"/>
                 <a:cs typeface="Arial" pitchFamily="34" charset="-120"/>
               </a:rPr>
-              <a:t>Prompt Ecology, Reverse Engineering —Embodied Agencies</a:t>
-            </a:r>
-            <a:endParaRPr lang="en-US" sz="750" dirty="0"/>
+              <a:t>EMBLEM-NLP | Prompt Ecology, Reverse Engineering —Embodied Agencies.</a:t>
+            </a:r>
+            <a:endParaRPr lang="en-US" sz="660" dirty="0"/>
           </a:p>
         </p:txBody>
       </p:sp>
@@ -8853,8 +8516,8 @@
         </p:blipFill>
         <p:spPr>
           <a:xfrm>
-            <a:off x="658368" y="1818132"/>
-            <a:ext cx="6537960" cy="3486912"/>
+            <a:off x="853717" y="1572768"/>
+            <a:ext cx="6147262" cy="3977640"/>
           </a:xfrm>
           <a:prstGeom prst="rect">
             <a:avLst/>
@@ -9064,24 +8727,26 @@
         </p:nvSpPr>
         <p:spPr>
           <a:xfrm>
-            <a:off x="2057400" y="6510528"/>
-            <a:ext cx="3931920" cy="182880"/>
-          </a:xfrm>
-          <a:prstGeom prst="rect">
-            <a:avLst/>
-          </a:prstGeom>
-          <a:noFill/>
-          <a:ln/>
-        </p:spPr>
-        <p:txBody>
-          <a:bodyPr wrap="square" lIns="0" tIns="0" rIns="0" bIns="0" rtlCol="0" anchor="ctr"/>
+            <a:off x="1874520" y="6510528"/>
+            <a:ext cx="4389120" cy="182880"/>
+          </a:xfrm>
+          <a:prstGeom prst="rect">
+            <a:avLst/>
+          </a:prstGeom>
+          <a:noFill/>
+          <a:ln/>
+        </p:spPr>
+        <p:txBody>
+          <a:bodyPr wrap="square" lIns="0" tIns="0" rIns="0" bIns="0" rtlCol="0" anchor="ctr">
+            <a:normAutofit/>
+          </a:bodyPr>
           <a:lstStyle/>
           <a:p>
             <a:pPr indent="0" marL="0">
               <a:buNone/>
             </a:pPr>
             <a:r>
-              <a:rPr lang="en-US" sz="750" dirty="0">
+              <a:rPr lang="en-US" sz="660" dirty="0">
                 <a:solidFill>
                   <a:srgbClr val="6B7280"/>
                 </a:solidFill>
@@ -9089,9 +8754,9 @@
                 <a:ea typeface="Arial" pitchFamily="34" charset="-122"/>
                 <a:cs typeface="Arial" pitchFamily="34" charset="-120"/>
               </a:rPr>
-              <a:t>Prompt Ecology, Reverse Engineering —Embodied Agencies</a:t>
-            </a:r>
-            <a:endParaRPr lang="en-US" sz="750" dirty="0"/>
+              <a:t>EMBLEM-NLP | Prompt Ecology, Reverse Engineering —Embodied Agencies.</a:t>
+            </a:r>
+            <a:endParaRPr lang="en-US" sz="660" dirty="0"/>
           </a:p>
         </p:txBody>
       </p:sp>
@@ -9536,24 +9201,26 @@
         </p:nvSpPr>
         <p:spPr>
           <a:xfrm>
-            <a:off x="2057400" y="6510528"/>
-            <a:ext cx="3931920" cy="182880"/>
-          </a:xfrm>
-          <a:prstGeom prst="rect">
-            <a:avLst/>
-          </a:prstGeom>
-          <a:noFill/>
-          <a:ln/>
-        </p:spPr>
-        <p:txBody>
-          <a:bodyPr wrap="square" lIns="0" tIns="0" rIns="0" bIns="0" rtlCol="0" anchor="ctr"/>
+            <a:off x="1874520" y="6510528"/>
+            <a:ext cx="4389120" cy="182880"/>
+          </a:xfrm>
+          <a:prstGeom prst="rect">
+            <a:avLst/>
+          </a:prstGeom>
+          <a:noFill/>
+          <a:ln/>
+        </p:spPr>
+        <p:txBody>
+          <a:bodyPr wrap="square" lIns="0" tIns="0" rIns="0" bIns="0" rtlCol="0" anchor="ctr">
+            <a:normAutofit/>
+          </a:bodyPr>
           <a:lstStyle/>
           <a:p>
             <a:pPr indent="0" marL="0">
               <a:buNone/>
             </a:pPr>
             <a:r>
-              <a:rPr lang="en-US" sz="750" dirty="0">
+              <a:rPr lang="en-US" sz="660" dirty="0">
                 <a:solidFill>
                   <a:srgbClr val="6B7280"/>
                 </a:solidFill>
@@ -9561,9 +9228,9 @@
                 <a:ea typeface="Arial" pitchFamily="34" charset="-122"/>
                 <a:cs typeface="Arial" pitchFamily="34" charset="-120"/>
               </a:rPr>
-              <a:t>Prompt Ecology, Reverse Engineering —Embodied Agencies</a:t>
-            </a:r>
-            <a:endParaRPr lang="en-US" sz="750" dirty="0"/>
+              <a:t>EMBLEM-NLP | Prompt Ecology, Reverse Engineering —Embodied Agencies.</a:t>
+            </a:r>
+            <a:endParaRPr lang="en-US" sz="660" dirty="0"/>
           </a:p>
         </p:txBody>
       </p:sp>
@@ -10008,24 +9675,26 @@
         </p:nvSpPr>
         <p:spPr>
           <a:xfrm>
-            <a:off x="2057400" y="6510528"/>
-            <a:ext cx="3931920" cy="182880"/>
-          </a:xfrm>
-          <a:prstGeom prst="rect">
-            <a:avLst/>
-          </a:prstGeom>
-          <a:noFill/>
-          <a:ln/>
-        </p:spPr>
-        <p:txBody>
-          <a:bodyPr wrap="square" lIns="0" tIns="0" rIns="0" bIns="0" rtlCol="0" anchor="ctr"/>
+            <a:off x="1874520" y="6510528"/>
+            <a:ext cx="4389120" cy="182880"/>
+          </a:xfrm>
+          <a:prstGeom prst="rect">
+            <a:avLst/>
+          </a:prstGeom>
+          <a:noFill/>
+          <a:ln/>
+        </p:spPr>
+        <p:txBody>
+          <a:bodyPr wrap="square" lIns="0" tIns="0" rIns="0" bIns="0" rtlCol="0" anchor="ctr">
+            <a:normAutofit/>
+          </a:bodyPr>
           <a:lstStyle/>
           <a:p>
             <a:pPr indent="0" marL="0">
               <a:buNone/>
             </a:pPr>
             <a:r>
-              <a:rPr lang="en-US" sz="750" dirty="0">
+              <a:rPr lang="en-US" sz="660" dirty="0">
                 <a:solidFill>
                   <a:srgbClr val="6B7280"/>
                 </a:solidFill>
@@ -10033,9 +9702,9 @@
                 <a:ea typeface="Arial" pitchFamily="34" charset="-122"/>
                 <a:cs typeface="Arial" pitchFamily="34" charset="-120"/>
               </a:rPr>
-              <a:t>Prompt Ecology, Reverse Engineering —Embodied Agencies</a:t>
-            </a:r>
-            <a:endParaRPr lang="en-US" sz="750" dirty="0"/>
+              <a:t>EMBLEM-NLP | Prompt Ecology, Reverse Engineering —Embodied Agencies.</a:t>
+            </a:r>
+            <a:endParaRPr lang="en-US" sz="660" dirty="0"/>
           </a:p>
         </p:txBody>
       </p:sp>

</xml_diff>